<commit_message>
Define arms A, B and C exactly in all decks; add The Three Data Arms slide
Co-Authored-By: Claude Sonnet 5.5 <noreply@anthropic.com>
Claude-Session: https://claude.ai/code/session_01Mrmk7xtGXEASaZHBUGuSEF
</commit_message>
<xml_diff>
--- a/DR_Final_5min.pptx
+++ b/DR_Final_5min.pptx
@@ -2076,7 +2076,7 @@
           <a:lstStyle/>
           <a:p>
             <a:r>
-              <a:t>[0:25] The method uses three arms: A is DDR only, B is DDR plus EyePACS source-balanced, and C is an earlier merge kept as a negative control. I add honest splits, a shortcut audit, and a frozen operating point at specificity 0.90 set on validation.</a:t>
+              <a:t>[0:25] The method uses three arms: A is DDR only, B is DDR plus all EyePACS grades, source-balanced, and C is DDR plus only EyePACS grades 1, 3 and 4, an old merge kept as a negative control. I add honest splits, a shortcut audit, and a frozen operating point at specificity 0.90 set on validation.</a:t>
             </a:r>
           </a:p>
         </p:txBody>
@@ -25489,7 +25489,7 @@
                 </a:solidFill>
                 <a:latin typeface="Arial"/>
               </a:rPr>
-              <a:t>A: DDR only. B: DDR + EyePACS, source-balanced. C: an earlier merge kept as a negative control</a:t>
+              <a:t>A: DDR only. B: DDR + all EyePACS grades, source-balanced. C: DDR + EyePACS grades 1, 3, 4 only, an old merge kept as a negative control</a:t>
             </a:r>
           </a:p>
           <a:p>

</xml_diff>

<commit_message>
Final deck: research question slide with the argument for why each question matters
Co-Authored-By: Claude Sonnet 5.5 <noreply@anthropic.com>
Claude-Session: https://claude.ai/code/session_01Mrmk7xtGXEASaZHBUGuSEF
</commit_message>
<xml_diff>
--- a/DR_Final_5min.pptx
+++ b/DR_Final_5min.pptx
@@ -2817,7 +2817,7 @@
           <a:lstStyle/>
           <a:p>
             <a:r>
-              <a:t>[0:30] So my main question is: when datasets are merged for early-DR detection, does the model learn the disease or the source? RQ1 tests the merge with a negative control. RQ2 asks whether a threshold frozen on validation survives a change of source. RQ3 asks whether external benchmarks carry capture cues like image size.</a:t>
+              <a:t>[0:40] So my main question is: when datasets are merged for early-DR detection, does the model learn the disease or the source? Merging is common, yet I found no study testing it. RQ1 asks whether adding EyePACS really helps, using a negative-control merge. RQ2 asks whether a threshold frozen on validation survives a change of source, because AUROC can hide over-flagging or missed early cases. RQ3 asks whether capture cues like image size are predicting the label. The contribution is a protocol to test DR models before trusting them, not a new network.</a:t>
             </a:r>
           </a:p>
         </p:txBody>
@@ -2887,7 +2887,7 @@
           <a:lstStyle/>
           <a:p>
             <a:r>
-              <a:t>[0:30] This builds on a few pieces. Gulshan and colleagues showed deep learning for referable DR. DDR, EyePACS and APTOS are my data sources, and temperature scaling gives calibrated outputs. A recent review and a cross-camera study describe dataset and camera effects, but for referable DR. I still need a systematic literature search.</a:t>
+              <a:t>[0:25] This builds on a few pieces. Gulshan and colleagues showed deep learning for referable DR. DDR, EyePACS and APTOS are my data sources, and temperature scaling gives calibrated outputs. A recent review and a cross-camera study describe dataset and camera effects, but for referable DR. I still need a systematic literature search.</a:t>
             </a:r>
           </a:p>
         </p:txBody>
@@ -2957,7 +2957,7 @@
           <a:lstStyle/>
           <a:p>
             <a:r>
-              <a:t>[0:30] How is this different? My target is early DR at a fixed specificity. I test the merge itself, compare imbalance methods one at a time with a control, test on held-out patients and an external set, and report shortcut audits and calibrated probabilities. It is not a new network: the value is the design and the evidence.</a:t>
+              <a:t>[0:25] How is this different? My target is early DR at a fixed specificity. I test the merge itself, compare imbalance methods one at a time with a control, test on held-out patients and an external set, and report shortcut audits and calibrated probabilities. It is not a new network: the value is the design and the evidence.</a:t>
             </a:r>
           </a:p>
         </p:txBody>
@@ -24411,7 +24411,7 @@
                 </a:solidFill>
                 <a:latin typeface="Arial"/>
               </a:rPr>
-              <a:t>What this project asks</a:t>
+              <a:t>What this project asks, and why it matters</a:t>
             </a:r>
           </a:p>
         </p:txBody>
@@ -24460,7 +24460,7 @@
         <p:spPr>
           <a:xfrm>
             <a:off x="502920" y="1280160"/>
-            <a:ext cx="8138160" cy="2926080"/>
+            <a:ext cx="8138160" cy="2971800"/>
           </a:xfrm>
           <a:prstGeom prst="roundRect">
             <a:avLst>
@@ -24500,7 +24500,7 @@
               </a:spcAft>
             </a:pPr>
             <a:r>
-              <a:rPr sz="1500" b="1">
+              <a:rPr sz="1400" b="1">
                 <a:solidFill>
                   <a:srgbClr val="121212"/>
                 </a:solidFill>
@@ -24509,13 +24509,13 @@
               <a:t>• Main question: </a:t>
             </a:r>
             <a:r>
-              <a:rPr sz="1400" b="0">
+              <a:rPr sz="1300" b="0">
                 <a:solidFill>
                   <a:srgbClr val="3a3a3a"/>
                 </a:solidFill>
                 <a:latin typeface="Arial"/>
               </a:rPr>
-              <a:t>when datasets are merged for early-DR detection, does the model learn the disease or the source?</a:t>
+              <a:t>when datasets are merged for early-DR detection, does the model learn the disease or the source? Why: merging is common, yet I found no study testing it</a:t>
             </a:r>
           </a:p>
           <a:p>
@@ -24525,22 +24525,22 @@
               </a:spcAft>
             </a:pPr>
             <a:r>
-              <a:rPr sz="1500" b="1">
+              <a:rPr sz="1400" b="1">
                 <a:solidFill>
                   <a:srgbClr val="121212"/>
                 </a:solidFill>
                 <a:latin typeface="Arial"/>
               </a:rPr>
-              <a:t>• RQ1: </a:t>
+              <a:t>• RQ1 (the merge): </a:t>
             </a:r>
             <a:r>
-              <a:rPr sz="1400" b="0">
+              <a:rPr sz="1300" b="0">
                 <a:solidFill>
                   <a:srgbClr val="3a3a3a"/>
                 </a:solidFill>
                 <a:latin typeface="Arial"/>
               </a:rPr>
-              <a:t>does adding EyePACS to DDR improve early-DR sensitivity at a fixed specificity on sources it has not seen? A negative-control merge tests this</a:t>
+              <a:t>does adding EyePACS to DDR improve early-DR sensitivity on unseen sources? Why: more data is assumed to help; a negative-control merge tests it</a:t>
             </a:r>
           </a:p>
           <a:p>
@@ -24550,22 +24550,22 @@
               </a:spcAft>
             </a:pPr>
             <a:r>
-              <a:rPr sz="1500" b="1">
+              <a:rPr sz="1400" b="1">
                 <a:solidFill>
                   <a:srgbClr val="121212"/>
                 </a:solidFill>
                 <a:latin typeface="Arial"/>
               </a:rPr>
-              <a:t>• RQ2: </a:t>
+              <a:t>• RQ2 (the threshold): </a:t>
             </a:r>
             <a:r>
-              <a:rPr sz="1400" b="0">
+              <a:rPr sz="1300" b="0">
                 <a:solidFill>
                   <a:srgbClr val="3a3a3a"/>
                 </a:solidFill>
                 <a:latin typeface="Arial"/>
               </a:rPr>
-              <a:t>does a threshold frozen on validation survive a change of source, and how much does own-source recalibration recover?</a:t>
+              <a:t>does a threshold frozen on validation survive a change of source? Why: AUROC can hide over-flagging, which overloads graders, or missed early cases</a:t>
             </a:r>
           </a:p>
           <a:p>
@@ -24575,22 +24575,76 @@
               </a:spcAft>
             </a:pPr>
             <a:r>
-              <a:rPr sz="1500" b="1">
+              <a:rPr sz="1400" b="1">
                 <a:solidFill>
                   <a:srgbClr val="121212"/>
                 </a:solidFill>
                 <a:latin typeface="Arial"/>
               </a:rPr>
-              <a:t>• RQ3: </a:t>
+              <a:t>• RQ3 (shortcuts): </a:t>
             </a:r>
             <a:r>
-              <a:rPr sz="1400" b="0">
+              <a:rPr sz="1300" b="0">
                 <a:solidFill>
                   <a:srgbClr val="3a3a3a"/>
                 </a:solidFill>
                 <a:latin typeface="Arial"/>
               </a:rPr>
-              <a:t>do external benchmarks carry capture cues, such as image size, that a model could use instead of disease?</a:t>
+              <a:t>does image size or another capture cue predict the label? Why: a model could be rewarded for the camera instead of the disease</a:t>
+            </a:r>
+          </a:p>
+        </p:txBody>
+      </p:sp>
+      <p:sp>
+        <p:nvSpPr>
+          <p:cNvPr id="202" name="Banner"/>
+          <p:cNvSpPr/>
+          <p:nvPr/>
+        </p:nvSpPr>
+        <p:spPr>
+          <a:xfrm>
+            <a:off x="502920" y="4315968"/>
+            <a:ext cx="8138160" cy="365760"/>
+          </a:xfrm>
+          <a:prstGeom prst="roundRect">
+            <a:avLst/>
+          </a:prstGeom>
+          <a:solidFill>
+            <a:srgbClr val="F2F5F8"/>
+          </a:solidFill>
+          <a:ln w="9525">
+            <a:solidFill>
+              <a:srgbClr val="CDD2D7"/>
+            </a:solidFill>
+          </a:ln>
+        </p:spPr>
+        <p:style>
+          <a:lnRef idx="1">
+            <a:schemeClr val="accent1"/>
+          </a:lnRef>
+          <a:fillRef idx="3">
+            <a:schemeClr val="accent1"/>
+          </a:fillRef>
+          <a:effectRef idx="2">
+            <a:schemeClr val="accent1"/>
+          </a:effectRef>
+          <a:fontRef idx="minor">
+            <a:schemeClr val="lt1"/>
+          </a:fontRef>
+        </p:style>
+        <p:txBody>
+          <a:bodyPr wrap="square" lIns="91440" tIns="36576" rIns="91440" bIns="36576" rtlCol="0" anchor="ctr"/>
+          <a:lstStyle/>
+          <a:p>
+            <a:pPr algn="ctr"/>
+            <a:r>
+              <a:rPr sz="1100" b="1">
+                <a:solidFill>
+                  <a:srgbClr val="121212"/>
+                </a:solidFill>
+                <a:latin typeface="Arial"/>
+              </a:rPr>
+              <a:t>The contribution is a protocol to test DR models before trusting them, not a new network.</a:t>
             </a:r>
           </a:p>
         </p:txBody>

</xml_diff>

<commit_message>
Frame research questions as general dataset merging with DR as case study; add image-property question
Co-Authored-By: Claude Sonnet 5.5 <noreply@anthropic.com>
Claude-Session: https://claude.ai/code/session_01Mrmk7xtGXEASaZHBUGuSEF
</commit_message>
<xml_diff>
--- a/DR_Final_5min.pptx
+++ b/DR_Final_5min.pptx
@@ -2076,7 +2076,7 @@
           <a:lstStyle/>
           <a:p>
             <a:r>
-              <a:t>[0:25] The method uses three arms: A is DDR only, B is DDR plus all EyePACS grades, source-balanced, and C is DDR plus only EyePACS grades 1, 3 and 4, an old merge kept as a negative control. I add honest splits, a shortcut audit, and a frozen operating point at specificity 0.90 set on validation.</a:t>
+              <a:t>[0:30] The method uses three arms. A is DDR only, B is DDR plus all EyePACS grades, source-balanced, and C is DDR plus only EyePACS grades 1, 3 and 4, an old merge kept as a negative control. I add honest splits, a property analysis of size, brightness, colour and sharpness, and a frozen operating point at specificity 0.90 set on validation.</a:t>
             </a:r>
           </a:p>
         </p:txBody>
@@ -2146,7 +2146,7 @@
           <a:lstStyle/>
           <a:p>
             <a:r>
-              <a:t>[0:25] The model is simple: a fundus image is cropped and resized, passed through an EfficientNet-B0, then calibrated with temperature scaling and a prior-shift correction. The output is a probability of early disease and a flag, all set on validation data only.</a:t>
+              <a:t>[0:20] The model is simple: a fundus image is cropped and resized, passed through an EfficientNet-B0, then calibrated with temperature scaling and a prior-shift correction. The output is a probability of early disease and a flag, all set on validation data only.</a:t>
             </a:r>
           </a:p>
         </p:txBody>
@@ -2216,7 +2216,7 @@
           <a:lstStyle/>
           <a:p>
             <a:r>
-              <a:t>[0:20] For data I use DDR, EyePACS split by patient, and APTOS as an external test only. The splits are frozen files, and test sets are opened only through a declared analysis.</a:t>
+              <a:t>[0:15] For data I use DDR, EyePACS split by patient, and APTOS as an external test only. The splits are frozen files, and test sets are opened only through a declared analysis.</a:t>
             </a:r>
           </a:p>
         </p:txBody>
@@ -2286,7 +2286,7 @@
           <a:lstStyle/>
           <a:p>
             <a:r>
-              <a:t>[0:15] Next steps: train the arms with several seeds, compare the imbalance methods, test on unseen sources with confidence intervals, and finish the literature search and thesis.</a:t>
+              <a:t>[0:20] Next steps: train the three arms with several seeds, compare the imbalance methods, analyse image properties, test on unseen sources with confidence intervals, report sensitivity at a fixed specificity, and finish the literature search and thesis.</a:t>
             </a:r>
           </a:p>
         </p:txBody>
@@ -2747,7 +2747,7 @@
           <a:lstStyle/>
           <a:p>
             <a:r>
-              <a:t>[0:35] Here is the gap. Public datasets like DDR, EyePACS and APTOS are often pooled to get more data. A recent review notes that multi-dataset training can mask poor external generalization, and I found no study testing whether a merged model learns the disease or the source. Accuracy can look excellent while the model over-flags or uses camera cues. An over-flagging tool overloads graders; an under-flagging one misses early disease.</a:t>
+              <a:t>[0:30] Here is the gap. Public medical-image datasets are often pooled; here DDR, EyePACS and APTOS. A recent review notes that multi-dataset training can mask poor external generalization. In other fields, models have learned hospital or scanner site instead of disease, in chest X-rays, and dataset identity in general. I found no study testing this for early DR, or which image properties carry it. An over-flagging tool overloads graders; an under-flagging one misses early disease.</a:t>
             </a:r>
           </a:p>
         </p:txBody>
@@ -2817,7 +2817,7 @@
           <a:lstStyle/>
           <a:p>
             <a:r>
-              <a:t>[0:40] So my main question is: when datasets are merged for early-DR detection, does the model learn the disease or the source? Merging is common, yet I found no study testing it. RQ1 asks whether adding EyePACS really helps, using a negative-control merge. RQ2 asks whether a threshold frozen on validation survives a change of source, because AUROC can hide over-flagging or missed early cases. RQ3 asks whether capture cues like image size are predicting the label. The contribution is a protocol to test DR models before trusting them, not a new network.</a:t>
+              <a:t>[0:35] My main question is general: when medical-image datasets are merged, does a model learn the condition or the source? Early DR is my case study. RQ1: does a second source really help on unseen sources? A negative-control merge tests it. RQ2: does a threshold frozen on validation survive a change of source? RQ3: which image properties differ between sources, such as size, quality, brightness and colour, and how do they affect what a merged model learns? The contribution is a protocol, not a new network.</a:t>
             </a:r>
           </a:p>
         </p:txBody>
@@ -2887,7 +2887,7 @@
           <a:lstStyle/>
           <a:p>
             <a:r>
-              <a:t>[0:25] This builds on a few pieces. Gulshan and colleagues showed deep learning for referable DR. DDR, EyePACS and APTOS are my data sources, and temperature scaling gives calibrated outputs. A recent review and a cross-camera study describe dataset and camera effects, but for referable DR. I still need a systematic literature search.</a:t>
+              <a:t>[0:25] This builds on a few pieces. Gulshan and colleagues for referable DR, my three datasets, and temperature scaling for calibration. Torralba and Efros, Geirhos, Zech and DeGrave show that models learn dataset or site cues. A DR review and a cross-camera study describe dataset and camera effects. I still need a systematic literature search.</a:t>
             </a:r>
           </a:p>
         </p:txBody>
@@ -2957,7 +2957,7 @@
           <a:lstStyle/>
           <a:p>
             <a:r>
-              <a:t>[0:25] How is this different? My target is early DR at a fixed specificity. I test the merge itself, compare imbalance methods one at a time with a control, test on held-out patients and an external set, and report shortcut audits and calibrated probabilities. It is not a new network: the value is the design and the evidence.</a:t>
+              <a:t>[0:25] How is this different? My target is early DR at a fixed specificity. I test the merge itself, compare imbalance methods one at a time, test on held-out patients and an external set, and ask which image properties carry the source. DR is the case study; the protocol should apply to any merged medical-image task. It is not a new network.</a:t>
             </a:r>
           </a:p>
         </p:txBody>
@@ -22136,7 +22136,7 @@
               </a:spcAft>
             </a:pPr>
             <a:r>
-              <a:rPr sz="1500" b="1">
+              <a:rPr sz="1400" b="1">
                 <a:solidFill>
                   <a:srgbClr val="121212"/>
                 </a:solidFill>
@@ -22145,7 +22145,7 @@
               <a:t>• Train the three arms: </a:t>
             </a:r>
             <a:r>
-              <a:rPr sz="1400" b="0">
+              <a:rPr sz="1300" b="0">
                 <a:solidFill>
                   <a:srgbClr val="3a3a3a"/>
                 </a:solidFill>
@@ -22161,7 +22161,7 @@
               </a:spcAft>
             </a:pPr>
             <a:r>
-              <a:rPr sz="1500" b="1">
+              <a:rPr sz="1400" b="1">
                 <a:solidFill>
                   <a:srgbClr val="121212"/>
                 </a:solidFill>
@@ -22170,7 +22170,7 @@
               <a:t>• Compare imbalance methods: </a:t>
             </a:r>
             <a:r>
-              <a:rPr sz="1400" b="0">
+              <a:rPr sz="1300" b="0">
                 <a:solidFill>
                   <a:srgbClr val="3a3a3a"/>
                 </a:solidFill>
@@ -22186,7 +22186,32 @@
               </a:spcAft>
             </a:pPr>
             <a:r>
-              <a:rPr sz="1500" b="1">
+              <a:rPr sz="1400" b="1">
+                <a:solidFill>
+                  <a:srgbClr val="121212"/>
+                </a:solidFill>
+                <a:latin typeface="Arial"/>
+              </a:rPr>
+              <a:t>• Analyse image properties: </a:t>
+            </a:r>
+            <a:r>
+              <a:rPr sz="1300" b="0">
+                <a:solidFill>
+                  <a:srgbClr val="3a3a3a"/>
+                </a:solidFill>
+                <a:latin typeface="Arial"/>
+              </a:rPr>
+              <a:t>source prediction, scores within matched groups, and normalisation tests</a:t>
+            </a:r>
+          </a:p>
+          <a:p>
+            <a:pPr algn="l">
+              <a:spcAft>
+                <a:spcPts val="900"/>
+              </a:spcAft>
+            </a:pPr>
+            <a:r>
+              <a:rPr sz="1400" b="1">
                 <a:solidFill>
                   <a:srgbClr val="121212"/>
                 </a:solidFill>
@@ -22195,7 +22220,7 @@
               <a:t>• Test on unseen sources: </a:t>
             </a:r>
             <a:r>
-              <a:rPr sz="1400" b="0">
+              <a:rPr sz="1300" b="0">
                 <a:solidFill>
                   <a:srgbClr val="3a3a3a"/>
                 </a:solidFill>
@@ -22211,7 +22236,7 @@
               </a:spcAft>
             </a:pPr>
             <a:r>
-              <a:rPr sz="1500" b="1">
+              <a:rPr sz="1400" b="1">
                 <a:solidFill>
                   <a:srgbClr val="121212"/>
                 </a:solidFill>
@@ -22220,7 +22245,7 @@
               <a:t>• Calibrate and report: </a:t>
             </a:r>
             <a:r>
-              <a:rPr sz="1400" b="0">
+              <a:rPr sz="1300" b="0">
                 <a:solidFill>
                   <a:srgbClr val="3a3a3a"/>
                 </a:solidFill>
@@ -22236,7 +22261,7 @@
               </a:spcAft>
             </a:pPr>
             <a:r>
-              <a:rPr sz="1500" b="1">
+              <a:rPr sz="1400" b="1">
                 <a:solidFill>
                   <a:srgbClr val="121212"/>
                 </a:solidFill>
@@ -22245,7 +22270,7 @@
               <a:t>• Write up: </a:t>
             </a:r>
             <a:r>
-              <a:rPr sz="1400" b="0">
+              <a:rPr sz="1300" b="0">
                 <a:solidFill>
                   <a:srgbClr val="3a3a3a"/>
                 </a:solidFill>
@@ -22504,6 +22529,234 @@
                 </a:solidFill>
               </a:rPr>
               <a:t>• Sipka, T., et al. The hitchhiker’s guide to prior-shift adaptation. WACV, 2022.</a:t>
+            </a:r>
+          </a:p>
+          <a:p>
+            <a:pPr algn="l">
+              <a:lnSpc>
+                <a:spcPct val="105000"/>
+              </a:lnSpc>
+              <a:spcAft>
+                <a:spcPts val="400"/>
+              </a:spcAft>
+            </a:pPr>
+            <a:r>
+              <a:rPr sz="919" dirty="0">
+                <a:solidFill>
+                  <a:srgbClr val="121212"/>
+                </a:solidFill>
+                <a:latin typeface="Arial"/>
+              </a:rPr>
+              <a:t>• Torralba, A., &amp; Efros, A. Unbiased look at dataset bias. CVPR, 2011.</a:t>
+            </a:r>
+          </a:p>
+          <a:p>
+            <a:pPr algn="l">
+              <a:lnSpc>
+                <a:spcPct val="105000"/>
+              </a:lnSpc>
+              <a:spcAft>
+                <a:spcPts val="400"/>
+              </a:spcAft>
+            </a:pPr>
+            <a:r>
+              <a:rPr sz="919" dirty="0">
+                <a:solidFill>
+                  <a:srgbClr val="121212"/>
+                </a:solidFill>
+                <a:latin typeface="Arial"/>
+              </a:rPr>
+              <a:t>• Geirhos, R., et al. Shortcut learning in deep neural networks. Nature Machine Intelligence, 2020.</a:t>
+            </a:r>
+          </a:p>
+          <a:p>
+            <a:pPr algn="l">
+              <a:lnSpc>
+                <a:spcPct val="105000"/>
+              </a:lnSpc>
+              <a:spcAft>
+                <a:spcPts val="400"/>
+              </a:spcAft>
+            </a:pPr>
+            <a:r>
+              <a:rPr sz="919" dirty="0">
+                <a:solidFill>
+                  <a:srgbClr val="121212"/>
+                </a:solidFill>
+                <a:latin typeface="Arial"/>
+              </a:rPr>
+              <a:t>• Zech, J. R., et al. Variable generalization performance of a deep learning model to detect pneumonia in chest radiographs. PLOS Medicine, 2018.</a:t>
+            </a:r>
+          </a:p>
+          <a:p>
+            <a:pPr algn="l">
+              <a:lnSpc>
+                <a:spcPct val="105000"/>
+              </a:lnSpc>
+              <a:spcAft>
+                <a:spcPts val="400"/>
+              </a:spcAft>
+            </a:pPr>
+            <a:r>
+              <a:rPr sz="919" dirty="0">
+                <a:solidFill>
+                  <a:srgbClr val="121212"/>
+                </a:solidFill>
+                <a:latin typeface="Arial"/>
+              </a:rPr>
+              <a:t>• DeGrave, A. J., et al. AI for radiographic COVID-19 detection selects shortcuts over signal. Nature Machine Intelligence, 2021.</a:t>
+            </a:r>
+          </a:p>
+          <a:p>
+            <a:pPr algn="l">
+              <a:lnSpc>
+                <a:spcPct val="105000"/>
+              </a:lnSpc>
+              <a:spcAft>
+                <a:spcPts val="400"/>
+              </a:spcAft>
+            </a:pPr>
+            <a:r>
+              <a:rPr sz="919" dirty="0">
+                <a:solidFill>
+                  <a:srgbClr val="121212"/>
+                </a:solidFill>
+                <a:latin typeface="Arial"/>
+              </a:rPr>
+              <a:t>• Gulshan, V., et al. Development and validation of a deep learning algorithm for detection of diabetic retinopathy. JAMA, 2016.</a:t>
+            </a:r>
+          </a:p>
+          <a:p>
+            <a:pPr algn="l">
+              <a:lnSpc>
+                <a:spcPct val="105000"/>
+              </a:lnSpc>
+              <a:spcAft>
+                <a:spcPts val="400"/>
+              </a:spcAft>
+            </a:pPr>
+            <a:r>
+              <a:rPr sz="919" dirty="0">
+                <a:solidFill>
+                  <a:srgbClr val="121212"/>
+                </a:solidFill>
+                <a:latin typeface="Arial"/>
+              </a:rPr>
+              <a:t>• Tan, M., &amp; Le, Q. EfficientNet: Rethinking model scaling for convolutional neural networks. ICML, 2019.</a:t>
+            </a:r>
+          </a:p>
+          <a:p>
+            <a:pPr algn="l">
+              <a:lnSpc>
+                <a:spcPct val="105000"/>
+              </a:lnSpc>
+              <a:spcAft>
+                <a:spcPts val="400"/>
+              </a:spcAft>
+            </a:pPr>
+            <a:r>
+              <a:rPr sz="919" dirty="0">
+                <a:solidFill>
+                  <a:srgbClr val="121212"/>
+                </a:solidFill>
+                <a:latin typeface="Arial"/>
+              </a:rPr>
+              <a:t>• From Retinal Pixels to Patients: Evolution of Deep Learning Research in Diabetic Retinopathy Screening. arXiv:2511.11065, 2025.</a:t>
+            </a:r>
+          </a:p>
+          <a:p>
+            <a:pPr algn="l">
+              <a:lnSpc>
+                <a:spcPct val="105000"/>
+              </a:lnSpc>
+              <a:spcAft>
+                <a:spcPts val="400"/>
+              </a:spcAft>
+            </a:pPr>
+            <a:r>
+              <a:rPr sz="919" dirty="0">
+                <a:solidFill>
+                  <a:srgbClr val="121212"/>
+                </a:solidFill>
+                <a:latin typeface="Arial"/>
+              </a:rPr>
+              <a:t>• Cross-camera external validation for artificial intelligence software in diagnosis of diabetic retinopathy. PMC8926465, 2022.</a:t>
+            </a:r>
+          </a:p>
+          <a:p>
+            <a:pPr algn="l">
+              <a:lnSpc>
+                <a:spcPct val="105000"/>
+              </a:lnSpc>
+              <a:spcAft>
+                <a:spcPts val="400"/>
+              </a:spcAft>
+            </a:pPr>
+            <a:r>
+              <a:rPr sz="919" dirty="0">
+                <a:solidFill>
+                  <a:srgbClr val="121212"/>
+                </a:solidFill>
+                <a:latin typeface="Arial"/>
+              </a:rPr>
+              <a:t>• Torralba, A., &amp; Efros, A. Unbiased look at dataset bias. CVPR, 2011.</a:t>
+            </a:r>
+          </a:p>
+          <a:p>
+            <a:pPr algn="l">
+              <a:lnSpc>
+                <a:spcPct val="105000"/>
+              </a:lnSpc>
+              <a:spcAft>
+                <a:spcPts val="400"/>
+              </a:spcAft>
+            </a:pPr>
+            <a:r>
+              <a:rPr sz="919" dirty="0">
+                <a:solidFill>
+                  <a:srgbClr val="121212"/>
+                </a:solidFill>
+                <a:latin typeface="Arial"/>
+              </a:rPr>
+              <a:t>• Geirhos, R., et al. Shortcut learning in deep neural networks. Nature Machine Intelligence, 2020.</a:t>
+            </a:r>
+          </a:p>
+          <a:p>
+            <a:pPr algn="l">
+              <a:lnSpc>
+                <a:spcPct val="105000"/>
+              </a:lnSpc>
+              <a:spcAft>
+                <a:spcPts val="400"/>
+              </a:spcAft>
+            </a:pPr>
+            <a:r>
+              <a:rPr sz="919" dirty="0">
+                <a:solidFill>
+                  <a:srgbClr val="121212"/>
+                </a:solidFill>
+                <a:latin typeface="Arial"/>
+              </a:rPr>
+              <a:t>• Zech, J. R., et al. Variable generalization performance of a deep learning model to detect pneumonia in chest radiographs. PLOS Medicine, 2018.</a:t>
+            </a:r>
+          </a:p>
+          <a:p>
+            <a:pPr algn="l">
+              <a:lnSpc>
+                <a:spcPct val="105000"/>
+              </a:lnSpc>
+              <a:spcAft>
+                <a:spcPts val="400"/>
+              </a:spcAft>
+            </a:pPr>
+            <a:r>
+              <a:rPr sz="919" dirty="0">
+                <a:solidFill>
+                  <a:srgbClr val="121212"/>
+                </a:solidFill>
+                <a:latin typeface="Arial"/>
+              </a:rPr>
+              <a:t>• DeGrave, A. J., et al. AI for radiographic COVID-19 detection selects shortcuts over signal. Nature Machine Intelligence, 2021.</a:t>
             </a:r>
           </a:p>
           <a:p>
@@ -24203,7 +24456,7 @@
               </a:spcAft>
             </a:pPr>
             <a:r>
-              <a:rPr sz="1400" b="1">
+              <a:rPr sz="1300" b="1">
                 <a:solidFill>
                   <a:srgbClr val="121212"/>
                 </a:solidFill>
@@ -24212,13 +24465,13 @@
               <a:t>• Pooling is common: </a:t>
             </a:r>
             <a:r>
-              <a:rPr sz="1300" b="0">
+              <a:rPr sz="1200" b="0">
                 <a:solidFill>
                   <a:srgbClr val="3a3a3a"/>
                 </a:solidFill>
                 <a:latin typeface="Arial"/>
               </a:rPr>
-              <a:t>public datasets (DDR, EyePACS, APTOS) are combined to get more training data</a:t>
+              <a:t>public medical-image datasets are combined to get more training data; here DDR, EyePACS and APTOS</a:t>
             </a:r>
           </a:p>
           <a:p>
@@ -24228,7 +24481,7 @@
               </a:spcAft>
             </a:pPr>
             <a:r>
-              <a:rPr sz="1400" b="1">
+              <a:rPr sz="1300" b="1">
                 <a:solidFill>
                   <a:srgbClr val="121212"/>
                 </a:solidFill>
@@ -24237,13 +24490,13 @@
               <a:t>• An untested assumption: </a:t>
             </a:r>
             <a:r>
-              <a:rPr sz="1300" b="0">
+              <a:rPr sz="1200" b="0">
                 <a:solidFill>
                   <a:srgbClr val="3a3a3a"/>
                 </a:solidFill>
                 <a:latin typeface="Arial"/>
               </a:rPr>
-              <a:t>a 2025 review notes that multi-dataset training can mask poor external generalization</a:t>
+              <a:t>a 2025 DR review notes that multi-dataset training can mask poor external generalization</a:t>
             </a:r>
           </a:p>
           <a:p>
@@ -24253,22 +24506,22 @@
               </a:spcAft>
             </a:pPr>
             <a:r>
-              <a:rPr sz="1400" b="1">
+              <a:rPr sz="1300" b="1">
                 <a:solidFill>
                   <a:srgbClr val="121212"/>
                 </a:solidFill>
                 <a:latin typeface="Arial"/>
               </a:rPr>
-              <a:t>• Not found: </a:t>
+              <a:t>• Known in other fields: </a:t>
             </a:r>
             <a:r>
-              <a:rPr sz="1300" b="0">
+              <a:rPr sz="1200" b="0">
                 <a:solidFill>
                   <a:srgbClr val="3a3a3a"/>
                 </a:solidFill>
                 <a:latin typeface="Arial"/>
               </a:rPr>
-              <a:t>a study testing whether a merged model learns the disease or the source dataset</a:t>
+              <a:t>models have learned hospital or scanner site instead of disease in chest X-rays (Zech 2018; DeGrave 2021) and dataset identity in general (Torralba and Efros 2011)</a:t>
             </a:r>
           </a:p>
           <a:p>
@@ -24278,7 +24531,32 @@
               </a:spcAft>
             </a:pPr>
             <a:r>
-              <a:rPr sz="1400" b="1">
+              <a:rPr sz="1300" b="1">
+                <a:solidFill>
+                  <a:srgbClr val="121212"/>
+                </a:solidFill>
+                <a:latin typeface="Arial"/>
+              </a:rPr>
+              <a:t>• Not found for early DR: </a:t>
+            </a:r>
+            <a:r>
+              <a:rPr sz="1200" b="0">
+                <a:solidFill>
+                  <a:srgbClr val="3a3a3a"/>
+                </a:solidFill>
+                <a:latin typeface="Arial"/>
+              </a:rPr>
+              <a:t>a study testing whether a merged model learns the disease or the source, or which image properties carry it</a:t>
+            </a:r>
+          </a:p>
+          <a:p>
+            <a:pPr algn="l">
+              <a:spcAft>
+                <a:spcPts val="900"/>
+              </a:spcAft>
+            </a:pPr>
+            <a:r>
+              <a:rPr sz="1300" b="1">
                 <a:solidFill>
                   <a:srgbClr val="121212"/>
                 </a:solidFill>
@@ -24287,13 +24565,13 @@
               <a:t>• Hidden failures: </a:t>
             </a:r>
             <a:r>
-              <a:rPr sz="1300" b="0">
+              <a:rPr sz="1200" b="0">
                 <a:solidFill>
                   <a:srgbClr val="3a3a3a"/>
                 </a:solidFill>
                 <a:latin typeface="Arial"/>
               </a:rPr>
-              <a:t>in-domain accuracy or AUROC can look excellent while a model over-flags, uses camera cues or misses its target at a new site</a:t>
+              <a:t>in-domain accuracy or AUROC can look excellent while a model over-flags, uses capture cues or misses its target at a new site</a:t>
             </a:r>
           </a:p>
           <a:p>
@@ -24303,7 +24581,7 @@
               </a:spcAft>
             </a:pPr>
             <a:r>
-              <a:rPr sz="1400" b="1">
+              <a:rPr sz="1300" b="1">
                 <a:solidFill>
                   <a:srgbClr val="121212"/>
                 </a:solidFill>
@@ -24312,7 +24590,7 @@
               <a:t>• Why it matters: </a:t>
             </a:r>
             <a:r>
-              <a:rPr sz="1300" b="0">
+              <a:rPr sz="1200" b="0">
                 <a:solidFill>
                   <a:srgbClr val="3a3a3a"/>
                 </a:solidFill>
@@ -24376,7 +24654,7 @@
                 </a:solidFill>
                 <a:latin typeface="Arial"/>
               </a:rPr>
-              <a:t>Research Question</a:t>
+              <a:t>Research Questions</a:t>
             </a:r>
           </a:p>
         </p:txBody>
@@ -24411,7 +24689,7 @@
                 </a:solidFill>
                 <a:latin typeface="Arial"/>
               </a:rPr>
-              <a:t>What this project asks, and why it matters</a:t>
+              <a:t>Dataset merging in general, with early DR as the case study</a:t>
             </a:r>
           </a:p>
         </p:txBody>
@@ -24500,7 +24778,7 @@
               </a:spcAft>
             </a:pPr>
             <a:r>
-              <a:rPr sz="1400" b="1">
+              <a:rPr sz="1350" b="1">
                 <a:solidFill>
                   <a:srgbClr val="121212"/>
                 </a:solidFill>
@@ -24509,13 +24787,13 @@
               <a:t>• Main question: </a:t>
             </a:r>
             <a:r>
-              <a:rPr sz="1300" b="0">
+              <a:rPr sz="1250" b="0">
                 <a:solidFill>
                   <a:srgbClr val="3a3a3a"/>
                 </a:solidFill>
                 <a:latin typeface="Arial"/>
               </a:rPr>
-              <a:t>when datasets are merged for early-DR detection, does the model learn the disease or the source? Why: merging is common, yet I found no study testing it</a:t>
+              <a:t>when medical-image datasets are merged, does a model learn the condition or the source? Case study: early DR, grades 1-2</a:t>
             </a:r>
           </a:p>
           <a:p>
@@ -24525,7 +24803,7 @@
               </a:spcAft>
             </a:pPr>
             <a:r>
-              <a:rPr sz="1400" b="1">
+              <a:rPr sz="1350" b="1">
                 <a:solidFill>
                   <a:srgbClr val="121212"/>
                 </a:solidFill>
@@ -24534,13 +24812,13 @@
               <a:t>• RQ1 (the merge): </a:t>
             </a:r>
             <a:r>
-              <a:rPr sz="1300" b="0">
+              <a:rPr sz="1250" b="0">
                 <a:solidFill>
                   <a:srgbClr val="3a3a3a"/>
                 </a:solidFill>
                 <a:latin typeface="Arial"/>
               </a:rPr>
-              <a:t>does adding EyePACS to DDR improve early-DR sensitivity on unseen sources? Why: more data is assumed to help; a negative-control merge tests it</a:t>
+              <a:t>does adding a second source improve sensitivity at a fixed specificity on unseen sources? A negative-control merge tests it</a:t>
             </a:r>
           </a:p>
           <a:p>
@@ -24550,7 +24828,7 @@
               </a:spcAft>
             </a:pPr>
             <a:r>
-              <a:rPr sz="1400" b="1">
+              <a:rPr sz="1350" b="1">
                 <a:solidFill>
                   <a:srgbClr val="121212"/>
                 </a:solidFill>
@@ -24559,13 +24837,13 @@
               <a:t>• RQ2 (the threshold): </a:t>
             </a:r>
             <a:r>
-              <a:rPr sz="1300" b="0">
+              <a:rPr sz="1250" b="0">
                 <a:solidFill>
                   <a:srgbClr val="3a3a3a"/>
                 </a:solidFill>
                 <a:latin typeface="Arial"/>
               </a:rPr>
-              <a:t>does a threshold frozen on validation survive a change of source? Why: AUROC can hide over-flagging, which overloads graders, or missed early cases</a:t>
+              <a:t>does a threshold frozen on validation survive a change of source? AUROC can hide over-flagging or missed cases</a:t>
             </a:r>
           </a:p>
           <a:p>
@@ -24575,22 +24853,22 @@
               </a:spcAft>
             </a:pPr>
             <a:r>
-              <a:rPr sz="1400" b="1">
+              <a:rPr sz="1350" b="1">
                 <a:solidFill>
                   <a:srgbClr val="121212"/>
                 </a:solidFill>
                 <a:latin typeface="Arial"/>
               </a:rPr>
-              <a:t>• RQ3 (shortcuts): </a:t>
+              <a:t>• RQ3 (image properties): </a:t>
             </a:r>
             <a:r>
-              <a:rPr sz="1300" b="0">
+              <a:rPr sz="1250" b="0">
                 <a:solidFill>
                   <a:srgbClr val="3a3a3a"/>
                 </a:solidFill>
                 <a:latin typeface="Arial"/>
               </a:rPr>
-              <a:t>does image size or another capture cue predict the label? Why: a model could be rewarded for the camera instead of the disease</a:t>
+              <a:t>which properties differ between sources (size, quality, brightness, colour, sharpness; camera proxies) and how do they affect what a merged model learns?</a:t>
             </a:r>
           </a:p>
         </p:txBody>
@@ -24644,7 +24922,7 @@
                 </a:solidFill>
                 <a:latin typeface="Arial"/>
               </a:rPr>
-              <a:t>The contribution is a protocol to test DR models before trusting them, not a new network.</a:t>
+              <a:t>The contribution is a protocol to test merged-data models before trusting them, not a new network.</a:t>
             </a:r>
           </a:p>
         </p:txBody>
@@ -24737,7 +25015,7 @@
                 </a:solidFill>
                 <a:latin typeface="Arial"/>
               </a:rPr>
-              <a:t>Data and methods this project builds on</a:t>
+              <a:t>Data, methods and prior evidence this project builds on</a:t>
             </a:r>
           </a:p>
         </p:txBody>
@@ -24826,7 +25104,7 @@
               </a:spcAft>
             </a:pPr>
             <a:r>
-              <a:rPr sz="1400" b="1">
+              <a:rPr sz="1300" b="1">
                 <a:solidFill>
                   <a:srgbClr val="121212"/>
                 </a:solidFill>
@@ -24835,7 +25113,7 @@
               <a:t>• Gulshan et al. (2016): </a:t>
             </a:r>
             <a:r>
-              <a:rPr sz="1300" b="0">
+              <a:rPr sz="1200" b="0">
                 <a:solidFill>
                   <a:srgbClr val="3a3a3a"/>
                 </a:solidFill>
@@ -24851,16 +25129,16 @@
               </a:spcAft>
             </a:pPr>
             <a:r>
-              <a:rPr sz="1400" b="1">
+              <a:rPr sz="1300" b="1">
                 <a:solidFill>
                   <a:srgbClr val="121212"/>
                 </a:solidFill>
                 <a:latin typeface="Arial"/>
               </a:rPr>
-              <a:t>• DDR (Li et al., 2019), EyePACS (Kaggle, 2015), APTOS 2019: </a:t>
+              <a:t>• DDR, EyePACS, APTOS: </a:t>
             </a:r>
             <a:r>
-              <a:rPr sz="1300" b="0">
+              <a:rPr sz="1200" b="0">
                 <a:solidFill>
                   <a:srgbClr val="3a3a3a"/>
                 </a:solidFill>
@@ -24876,7 +25154,7 @@
               </a:spcAft>
             </a:pPr>
             <a:r>
-              <a:rPr sz="1400" b="1">
+              <a:rPr sz="1300" b="1">
                 <a:solidFill>
                   <a:srgbClr val="121212"/>
                 </a:solidFill>
@@ -24885,7 +25163,7 @@
               <a:t>• Guo et al. (2017): </a:t>
             </a:r>
             <a:r>
-              <a:rPr sz="1300" b="0">
+              <a:rPr sz="1200" b="0">
                 <a:solidFill>
                   <a:srgbClr val="3a3a3a"/>
                 </a:solidFill>
@@ -24901,22 +25179,22 @@
               </a:spcAft>
             </a:pPr>
             <a:r>
-              <a:rPr sz="1400" b="1">
+              <a:rPr sz="1300" b="1">
                 <a:solidFill>
                   <a:srgbClr val="121212"/>
                 </a:solidFill>
                 <a:latin typeface="Arial"/>
               </a:rPr>
-              <a:t>• Recent review (arXiv, 2025): </a:t>
+              <a:t>• Dataset bias and shortcuts: </a:t>
             </a:r>
             <a:r>
-              <a:rPr sz="1300" b="0">
+              <a:rPr sz="1200" b="0">
                 <a:solidFill>
                   <a:srgbClr val="3a3a3a"/>
                 </a:solidFill>
                 <a:latin typeface="Arial"/>
               </a:rPr>
-              <a:t>describes cross-dataset degradation and the need for external test sets</a:t>
+              <a:t>Torralba and Efros (2011), Geirhos et al. (2020), Zech et al. (2018), DeGrave et al. (2021): models learn dataset or site cues</a:t>
             </a:r>
           </a:p>
           <a:p>
@@ -24926,22 +25204,22 @@
               </a:spcAft>
             </a:pPr>
             <a:r>
-              <a:rPr sz="1400" b="1">
+              <a:rPr sz="1300" b="1">
                 <a:solidFill>
                   <a:srgbClr val="121212"/>
                 </a:solidFill>
                 <a:latin typeface="Arial"/>
               </a:rPr>
-              <a:t>• Cross-camera validation (2022): </a:t>
+              <a:t>• DR reviews and camera studies: </a:t>
             </a:r>
             <a:r>
-              <a:rPr sz="1300" b="0">
+              <a:rPr sz="1200" b="0">
                 <a:solidFill>
                   <a:srgbClr val="3a3a3a"/>
                 </a:solidFill>
                 <a:latin typeface="Arial"/>
               </a:rPr>
-              <a:t>one DR software tested across camera models, for referable DR only</a:t>
+              <a:t>a 2025 review on cross-dataset degradation; a 2022 cross-camera study for referable DR</a:t>
             </a:r>
           </a:p>
         </p:txBody>
@@ -25177,7 +25455,7 @@
               </a:spcAft>
             </a:pPr>
             <a:r>
-              <a:rPr sz="1500" b="1">
+              <a:rPr sz="1400" b="1">
                 <a:solidFill>
                   <a:srgbClr val="121212"/>
                 </a:solidFill>
@@ -25186,7 +25464,7 @@
               <a:t>• Target: </a:t>
             </a:r>
             <a:r>
-              <a:rPr sz="1400" b="0">
+              <a:rPr sz="1300" b="0">
                 <a:solidFill>
                   <a:srgbClr val="3a3a3a"/>
                 </a:solidFill>
@@ -25202,7 +25480,7 @@
               </a:spcAft>
             </a:pPr>
             <a:r>
-              <a:rPr sz="1500" b="1">
+              <a:rPr sz="1400" b="1">
                 <a:solidFill>
                   <a:srgbClr val="121212"/>
                 </a:solidFill>
@@ -25211,7 +25489,7 @@
               <a:t>• Data: </a:t>
             </a:r>
             <a:r>
-              <a:rPr sz="1400" b="0">
+              <a:rPr sz="1300" b="0">
                 <a:solidFill>
                   <a:srgbClr val="3a3a3a"/>
                 </a:solidFill>
@@ -25227,7 +25505,7 @@
               </a:spcAft>
             </a:pPr>
             <a:r>
-              <a:rPr sz="1500" b="1">
+              <a:rPr sz="1400" b="1">
                 <a:solidFill>
                   <a:srgbClr val="121212"/>
                 </a:solidFill>
@@ -25236,7 +25514,7 @@
               <a:t>• Imbalance: </a:t>
             </a:r>
             <a:r>
-              <a:rPr sz="1400" b="0">
+              <a:rPr sz="1300" b="0">
                 <a:solidFill>
                   <a:srgbClr val="3a3a3a"/>
                 </a:solidFill>
@@ -25252,7 +25530,7 @@
               </a:spcAft>
             </a:pPr>
             <a:r>
-              <a:rPr sz="1500" b="1">
+              <a:rPr sz="1400" b="1">
                 <a:solidFill>
                   <a:srgbClr val="121212"/>
                 </a:solidFill>
@@ -25261,7 +25539,7 @@
               <a:t>• Transfer: </a:t>
             </a:r>
             <a:r>
-              <a:rPr sz="1400" b="0">
+              <a:rPr sz="1300" b="0">
                 <a:solidFill>
                   <a:srgbClr val="3a3a3a"/>
                 </a:solidFill>
@@ -25277,22 +25555,47 @@
               </a:spcAft>
             </a:pPr>
             <a:r>
-              <a:rPr sz="1500" b="1">
+              <a:rPr sz="1400" b="1">
                 <a:solidFill>
                   <a:srgbClr val="121212"/>
                 </a:solidFill>
                 <a:latin typeface="Arial"/>
               </a:rPr>
-              <a:t>• Evidence: </a:t>
+              <a:t>• Properties: </a:t>
             </a:r>
             <a:r>
-              <a:rPr sz="1400" b="0">
+              <a:rPr sz="1300" b="0">
                 <a:solidFill>
                   <a:srgbClr val="3a3a3a"/>
                 </a:solidFill>
                 <a:latin typeface="Arial"/>
               </a:rPr>
-              <a:t>shortcut audits and calibrated probabilities, not just accuracy</a:t>
+              <a:t>which image properties carry the source, found by prediction, stratification and matching</a:t>
+            </a:r>
+          </a:p>
+          <a:p>
+            <a:pPr algn="l">
+              <a:spcAft>
+                <a:spcPts val="900"/>
+              </a:spcAft>
+            </a:pPr>
+            <a:r>
+              <a:rPr sz="1400" b="1">
+                <a:solidFill>
+                  <a:srgbClr val="121212"/>
+                </a:solidFill>
+                <a:latin typeface="Arial"/>
+              </a:rPr>
+              <a:t>• Scope: </a:t>
+            </a:r>
+            <a:r>
+              <a:rPr sz="1300" b="0">
+                <a:solidFill>
+                  <a:srgbClr val="3a3a3a"/>
+                </a:solidFill>
+                <a:latin typeface="Arial"/>
+              </a:rPr>
+              <a:t>DR is the case study; the protocol is written to apply to any merged medical-image task</a:t>
             </a:r>
           </a:p>
         </p:txBody>
@@ -25528,7 +25831,7 @@
               </a:spcAft>
             </a:pPr>
             <a:r>
-              <a:rPr sz="1400" b="1">
+              <a:rPr sz="1350" b="1">
                 <a:solidFill>
                   <a:srgbClr val="121212"/>
                 </a:solidFill>
@@ -25537,7 +25840,7 @@
               <a:t>• Three data arms: </a:t>
             </a:r>
             <a:r>
-              <a:rPr sz="1300" b="0">
+              <a:rPr sz="1250" b="0">
                 <a:solidFill>
                   <a:srgbClr val="3a3a3a"/>
                 </a:solidFill>
@@ -25553,7 +25856,7 @@
               </a:spcAft>
             </a:pPr>
             <a:r>
-              <a:rPr sz="1400" b="1">
+              <a:rPr sz="1350" b="1">
                 <a:solidFill>
                   <a:srgbClr val="121212"/>
                 </a:solidFill>
@@ -25562,7 +25865,7 @@
               <a:t>• Imbalance, one at a time: </a:t>
             </a:r>
             <a:r>
-              <a:rPr sz="1300" b="0">
+              <a:rPr sz="1250" b="0">
                 <a:solidFill>
                   <a:srgbClr val="3a3a3a"/>
                 </a:solidFill>
@@ -25578,7 +25881,7 @@
               </a:spcAft>
             </a:pPr>
             <a:r>
-              <a:rPr sz="1400" b="1">
+              <a:rPr sz="1350" b="1">
                 <a:solidFill>
                   <a:srgbClr val="121212"/>
                 </a:solidFill>
@@ -25587,7 +25890,7 @@
               <a:t>• Honest splits: </a:t>
             </a:r>
             <a:r>
-              <a:rPr sz="1300" b="0">
+              <a:rPr sz="1250" b="0">
                 <a:solidFill>
                   <a:srgbClr val="3a3a3a"/>
                 </a:solidFill>
@@ -25603,22 +25906,22 @@
               </a:spcAft>
             </a:pPr>
             <a:r>
-              <a:rPr sz="1400" b="1">
+              <a:rPr sz="1350" b="1">
                 <a:solidFill>
                   <a:srgbClr val="121212"/>
                 </a:solidFill>
                 <a:latin typeface="Arial"/>
               </a:rPr>
-              <a:t>• Shortcut audit: </a:t>
+              <a:t>• Property analysis: </a:t>
             </a:r>
             <a:r>
-              <a:rPr sz="1300" b="0">
+              <a:rPr sz="1250" b="0">
                 <a:solidFill>
                   <a:srgbClr val="3a3a3a"/>
                 </a:solidFill>
                 <a:latin typeface="Arial"/>
               </a:rPr>
-              <a:t>test whether image size, file size, colour or sharpness alone predict the label</a:t>
+              <a:t>can size, file size, brightness, colour or sharpness predict the source or the label, and do scores hold within matched groups?</a:t>
             </a:r>
           </a:p>
           <a:p>
@@ -25628,7 +25931,7 @@
               </a:spcAft>
             </a:pPr>
             <a:r>
-              <a:rPr sz="1400" b="1">
+              <a:rPr sz="1350" b="1">
                 <a:solidFill>
                   <a:srgbClr val="121212"/>
                 </a:solidFill>
@@ -25637,7 +25940,7 @@
               <a:t>• Frozen operating point: </a:t>
             </a:r>
             <a:r>
-              <a:rPr sz="1300" b="0">
+              <a:rPr sz="1250" b="0">
                 <a:solidFill>
                   <a:srgbClr val="3a3a3a"/>
                 </a:solidFill>

</xml_diff>